<commit_message>
Add DocIndex upload/remove and complete handoff documentation
Let maintainers manage documents in the web UI (upload, remove, DocIndex
pruning), refresh all handoff docs and the slide deck, and rewrite the
RAG interface README for multi-turn chat and current configuration.

Co-authored-by: Cursor <cursoragent@cursor.com>
</commit_message>
<xml_diff>
--- a/docs/PageIndex_Handoff.pptx
+++ b/docs/PageIndex_Handoff.pptx
@@ -25,6 +25,7 @@
     <p:sldId id="273" r:id="rId24"/>
     <p:sldId id="274" r:id="rId25"/>
     <p:sldId id="275" r:id="rId26"/>
+    <p:sldId id="276" r:id="rId27"/>
   </p:sldIdLst>
   <p:sldSz cx="9144000" cy="6858000" type="screen4x3"/>
   <p:notesSz cx="6858000" cy="9144000"/>
@@ -3361,7 +3362,7 @@
               </a:defRPr>
             </a:pPr>
             <a:r>
-              <a:t>VTTI AI Chatbot</a:t>
+              <a:t>VTTI AI Chatbot (port 5001)</a:t>
             </a:r>
           </a:p>
           <a:p>
@@ -3391,7 +3392,7 @@
               </a:defRPr>
             </a:pPr>
             <a:r>
-              <a:t>http://localhost:5001</a:t>
+              <a:t>Multi-turn Q&amp;A + session history</a:t>
             </a:r>
           </a:p>
           <a:p>
@@ -3406,7 +3407,7 @@
               </a:defRPr>
             </a:pPr>
             <a:r>
-              <a:t>Multi-turn Q&amp;A with session history</a:t>
+              <a:t>SSE progress + source citations</a:t>
             </a:r>
           </a:p>
           <a:p>
@@ -3421,22 +3422,7 @@
               </a:defRPr>
             </a:pPr>
             <a:r>
-              <a:t>Progress streaming + clickable source citations</a:t>
-            </a:r>
-          </a:p>
-          <a:p>
-            <a:pPr>
-              <a:spcAft>
-                <a:spcPts val="800"/>
-              </a:spcAft>
-              <a:defRPr sz="1500">
-                <a:solidFill>
-                  <a:srgbClr val="1E293B"/>
-                </a:solidFill>
-              </a:defRPr>
-            </a:pPr>
-            <a:r>
-              <a:t>Requires results/DocIndex.json</a:t>
+              <a:t>See RAG-Interface/README.md</a:t>
             </a:r>
           </a:p>
         </p:txBody>
@@ -3509,7 +3495,7 @@
               </a:defRPr>
             </a:pPr>
             <a:r>
-              <a:t>DocIndex Manager</a:t>
+              <a:t>DocIndex Manager (port 5002)</a:t>
             </a:r>
           </a:p>
           <a:p>
@@ -3539,7 +3525,7 @@
               </a:defRPr>
             </a:pPr>
             <a:r>
-              <a:t>http://localhost:5002</a:t>
+              <a:t>Upload PDFs to Database/</a:t>
             </a:r>
           </a:p>
           <a:p>
@@ -3554,7 +3540,7 @@
               </a:defRPr>
             </a:pPr>
             <a:r>
-              <a:t>List PDFs, trigger re-index jobs</a:t>
+              <a:t>Index, re-index, or remove documents</a:t>
             </a:r>
           </a:p>
           <a:p>
@@ -3569,7 +3555,7 @@
               </a:defRPr>
             </a:pPr>
             <a:r>
-              <a:t>Add PDFs by copying to Database/</a:t>
+              <a:t>See DocIndex-Interface/README.md</a:t>
             </a:r>
           </a:p>
         </p:txBody>
@@ -3583,6 +3569,258 @@
 </file>
 
 <file path=ppt/slides/slide11.xml><?xml version="1.0" encoding="utf-8"?>
+<p:sld xmlns:a="http://schemas.openxmlformats.org/drawingml/2006/main" xmlns:p="http://schemas.openxmlformats.org/presentationml/2006/main" xmlns:r="http://schemas.openxmlformats.org/officeDocument/2006/relationships">
+  <p:cSld>
+    <p:bg>
+      <p:bgPr>
+        <a:solidFill>
+          <a:srgbClr val="FFFFFF"/>
+        </a:solidFill>
+        <a:effectLst/>
+      </p:bgPr>
+    </p:bg>
+    <p:spTree>
+      <p:nvGrpSpPr>
+        <p:cNvPr id="1" name=""/>
+        <p:cNvGrpSpPr/>
+        <p:nvPr/>
+      </p:nvGrpSpPr>
+      <p:grpSpPr/>
+      <p:sp>
+        <p:nvSpPr>
+          <p:cNvPr id="2" name="Rectangle 1"/>
+          <p:cNvSpPr/>
+          <p:nvPr/>
+        </p:nvSpPr>
+        <p:spPr>
+          <a:xfrm>
+            <a:off x="0" y="0"/>
+            <a:ext cx="9144000" cy="822960"/>
+          </a:xfrm>
+          <a:prstGeom prst="rect">
+            <a:avLst/>
+          </a:prstGeom>
+          <a:solidFill>
+            <a:srgbClr val="0D9488"/>
+          </a:solidFill>
+          <a:ln>
+            <a:noFill/>
+          </a:ln>
+        </p:spPr>
+        <p:style>
+          <a:lnRef idx="1">
+            <a:schemeClr val="accent1"/>
+          </a:lnRef>
+          <a:fillRef idx="3">
+            <a:schemeClr val="accent1"/>
+          </a:fillRef>
+          <a:effectRef idx="2">
+            <a:schemeClr val="accent1"/>
+          </a:effectRef>
+          <a:fontRef idx="minor">
+            <a:schemeClr val="lt1"/>
+          </a:fontRef>
+        </p:style>
+        <p:txBody>
+          <a:bodyPr rtlCol="0" anchor="ctr"/>
+          <a:lstStyle/>
+          <a:p>
+            <a:pPr algn="ctr"/>
+          </a:p>
+        </p:txBody>
+      </p:sp>
+      <p:sp>
+        <p:nvSpPr>
+          <p:cNvPr id="3" name="TextBox 2"/>
+          <p:cNvSpPr txBox="1"/>
+          <p:nvPr/>
+        </p:nvSpPr>
+        <p:spPr>
+          <a:xfrm>
+            <a:off x="457200" y="137160"/>
+            <a:ext cx="8229600" cy="640080"/>
+          </a:xfrm>
+          <a:prstGeom prst="rect">
+            <a:avLst/>
+          </a:prstGeom>
+          <a:noFill/>
+        </p:spPr>
+        <p:txBody>
+          <a:bodyPr wrap="none">
+            <a:spAutoFit/>
+          </a:bodyPr>
+          <a:lstStyle/>
+          <a:p>
+            <a:pPr>
+              <a:defRPr sz="2800" b="1">
+                <a:solidFill>
+                  <a:srgbClr val="FFFFFF"/>
+                </a:solidFill>
+              </a:defRPr>
+            </a:pPr>
+            <a:r>
+              <a:t>DocIndex Manager — Document Lifecycle</a:t>
+            </a:r>
+          </a:p>
+        </p:txBody>
+      </p:sp>
+      <p:sp>
+        <p:nvSpPr>
+          <p:cNvPr id="4" name="TextBox 3"/>
+          <p:cNvSpPr txBox="1"/>
+          <p:nvPr/>
+        </p:nvSpPr>
+        <p:spPr>
+          <a:xfrm>
+            <a:off x="502920" y="914400"/>
+            <a:ext cx="8229600" cy="365760"/>
+          </a:xfrm>
+          <a:prstGeom prst="rect">
+            <a:avLst/>
+          </a:prstGeom>
+          <a:noFill/>
+        </p:spPr>
+        <p:txBody>
+          <a:bodyPr wrap="none">
+            <a:spAutoFit/>
+          </a:bodyPr>
+          <a:lstStyle/>
+          <a:p>
+            <a:pPr>
+              <a:defRPr sz="1400" i="1">
+                <a:solidFill>
+                  <a:srgbClr val="475569"/>
+                </a:solidFill>
+              </a:defRPr>
+            </a:pPr>
+            <a:r>
+              <a:t>http://localhost:5002</a:t>
+            </a:r>
+          </a:p>
+        </p:txBody>
+      </p:sp>
+      <p:sp>
+        <p:nvSpPr>
+          <p:cNvPr id="5" name="TextBox 4"/>
+          <p:cNvSpPr txBox="1"/>
+          <p:nvPr/>
+        </p:nvSpPr>
+        <p:spPr>
+          <a:xfrm>
+            <a:off x="502920" y="1325880"/>
+            <a:ext cx="8229600" cy="5303520"/>
+          </a:xfrm>
+          <a:prstGeom prst="rect">
+            <a:avLst/>
+          </a:prstGeom>
+          <a:noFill/>
+        </p:spPr>
+        <p:txBody>
+          <a:bodyPr wrap="square" anchor="t">
+            <a:spAutoFit/>
+          </a:bodyPr>
+          <a:lstStyle/>
+          <a:p>
+            <a:pPr>
+              <a:spcAft>
+                <a:spcPts val="1000"/>
+              </a:spcAft>
+              <a:defRPr sz="1800">
+                <a:solidFill>
+                  <a:srgbClr val="1E293B"/>
+                </a:solidFill>
+              </a:defRPr>
+            </a:pPr>
+            <a:r>
+              <a:t>Upload: drag-and-drop or file picker → saves to Database/</a:t>
+            </a:r>
+          </a:p>
+          <a:p>
+            <a:pPr>
+              <a:spcAft>
+                <a:spcPts val="1000"/>
+              </a:spcAft>
+              <a:defRPr sz="1800">
+                <a:solidFill>
+                  <a:srgbClr val="1E293B"/>
+                </a:solidFill>
+              </a:defRPr>
+            </a:pPr>
+            <a:r>
+              <a:t>Add Structure: run_pageindex.py --update_docindex for one PDF</a:t>
+            </a:r>
+          </a:p>
+          <a:p>
+            <a:pPr>
+              <a:spcAft>
+                <a:spcPts val="1000"/>
+              </a:spcAft>
+              <a:defRPr sz="1800">
+                <a:solidFill>
+                  <a:srgbClr val="1E293B"/>
+                </a:solidFill>
+              </a:defRPr>
+            </a:pPr>
+            <a:r>
+              <a:t>Update Structure: re-index after PDF or config changes</a:t>
+            </a:r>
+          </a:p>
+          <a:p>
+            <a:pPr>
+              <a:spcAft>
+                <a:spcPts val="1000"/>
+              </a:spcAft>
+              <a:defRPr sz="1800">
+                <a:solidFill>
+                  <a:srgbClr val="1E293B"/>
+                </a:solidFill>
+              </a:defRPr>
+            </a:pPr>
+            <a:r>
+              <a:t>Remove: delete Database/ file + structure JSON + DocIndex keywords</a:t>
+            </a:r>
+          </a:p>
+          <a:p>
+            <a:pPr>
+              <a:spcAft>
+                <a:spcPts val="1000"/>
+              </a:spcAft>
+              <a:defRPr sz="1800">
+                <a:solidFill>
+                  <a:srgbClr val="1E293B"/>
+                </a:solidFill>
+              </a:defRPr>
+            </a:pPr>
+            <a:r>
+              <a:t>Reconstruct: build_docindex.py over all PDFs in Database/</a:t>
+            </a:r>
+          </a:p>
+          <a:p>
+            <a:pPr>
+              <a:spcAft>
+                <a:spcPts val="1000"/>
+              </a:spcAft>
+              <a:defRPr sz="1800">
+                <a:solidFill>
+                  <a:srgbClr val="1E293B"/>
+                </a:solidFill>
+              </a:defRPr>
+            </a:pPr>
+            <a:r>
+              <a:t>Restart server after code updates (Ctrl+C → python app.py)</a:t>
+            </a:r>
+          </a:p>
+        </p:txBody>
+      </p:sp>
+    </p:spTree>
+  </p:cSld>
+  <p:clrMapOvr>
+    <a:masterClrMapping/>
+  </p:clrMapOvr>
+</p:sld>
+</file>
+
+<file path=ppt/slides/slide12.xml><?xml version="1.0" encoding="utf-8"?>
 <p:sld xmlns:a="http://schemas.openxmlformats.org/drawingml/2006/main" xmlns:p="http://schemas.openxmlformats.org/presentationml/2006/main" xmlns:r="http://schemas.openxmlformats.org/officeDocument/2006/relationships">
   <p:cSld>
     <p:bg>
@@ -3631,253 +3869,6 @@
             </a:pPr>
             <a:r>
               <a:t>Configuration</a:t>
-            </a:r>
-          </a:p>
-        </p:txBody>
-      </p:sp>
-    </p:spTree>
-  </p:cSld>
-  <p:clrMapOvr>
-    <a:masterClrMapping/>
-  </p:clrMapOvr>
-</p:sld>
-</file>
-
-<file path=ppt/slides/slide12.xml><?xml version="1.0" encoding="utf-8"?>
-<p:sld xmlns:a="http://schemas.openxmlformats.org/drawingml/2006/main" xmlns:p="http://schemas.openxmlformats.org/presentationml/2006/main" xmlns:r="http://schemas.openxmlformats.org/officeDocument/2006/relationships">
-  <p:cSld>
-    <p:bg>
-      <p:bgPr>
-        <a:solidFill>
-          <a:srgbClr val="FFFFFF"/>
-        </a:solidFill>
-        <a:effectLst/>
-      </p:bgPr>
-    </p:bg>
-    <p:spTree>
-      <p:nvGrpSpPr>
-        <p:cNvPr id="1" name=""/>
-        <p:cNvGrpSpPr/>
-        <p:nvPr/>
-      </p:nvGrpSpPr>
-      <p:grpSpPr/>
-      <p:sp>
-        <p:nvSpPr>
-          <p:cNvPr id="2" name="Rectangle 1"/>
-          <p:cNvSpPr/>
-          <p:nvPr/>
-        </p:nvSpPr>
-        <p:spPr>
-          <a:xfrm>
-            <a:off x="0" y="0"/>
-            <a:ext cx="9144000" cy="822960"/>
-          </a:xfrm>
-          <a:prstGeom prst="rect">
-            <a:avLst/>
-          </a:prstGeom>
-          <a:solidFill>
-            <a:srgbClr val="0D9488"/>
-          </a:solidFill>
-          <a:ln>
-            <a:noFill/>
-          </a:ln>
-        </p:spPr>
-        <p:style>
-          <a:lnRef idx="1">
-            <a:schemeClr val="accent1"/>
-          </a:lnRef>
-          <a:fillRef idx="3">
-            <a:schemeClr val="accent1"/>
-          </a:fillRef>
-          <a:effectRef idx="2">
-            <a:schemeClr val="accent1"/>
-          </a:effectRef>
-          <a:fontRef idx="minor">
-            <a:schemeClr val="lt1"/>
-          </a:fontRef>
-        </p:style>
-        <p:txBody>
-          <a:bodyPr rtlCol="0" anchor="ctr"/>
-          <a:lstStyle/>
-          <a:p>
-            <a:pPr algn="ctr"/>
-          </a:p>
-        </p:txBody>
-      </p:sp>
-      <p:sp>
-        <p:nvSpPr>
-          <p:cNvPr id="3" name="TextBox 2"/>
-          <p:cNvSpPr txBox="1"/>
-          <p:nvPr/>
-        </p:nvSpPr>
-        <p:spPr>
-          <a:xfrm>
-            <a:off x="457200" y="137160"/>
-            <a:ext cx="8229600" cy="640080"/>
-          </a:xfrm>
-          <a:prstGeom prst="rect">
-            <a:avLst/>
-          </a:prstGeom>
-          <a:noFill/>
-        </p:spPr>
-        <p:txBody>
-          <a:bodyPr wrap="none">
-            <a:spAutoFit/>
-          </a:bodyPr>
-          <a:lstStyle/>
-          <a:p>
-            <a:pPr>
-              <a:defRPr sz="2800" b="1">
-                <a:solidFill>
-                  <a:srgbClr val="FFFFFF"/>
-                </a:solidFill>
-              </a:defRPr>
-            </a:pPr>
-            <a:r>
-              <a:t>Current Default Setup (Hybrid)</a:t>
-            </a:r>
-          </a:p>
-        </p:txBody>
-      </p:sp>
-      <p:sp>
-        <p:nvSpPr>
-          <p:cNvPr id="4" name="TextBox 3"/>
-          <p:cNvSpPr txBox="1"/>
-          <p:nvPr/>
-        </p:nvSpPr>
-        <p:spPr>
-          <a:xfrm>
-            <a:off x="502920" y="1051560"/>
-            <a:ext cx="8229600" cy="5303520"/>
-          </a:xfrm>
-          <a:prstGeom prst="rect">
-            <a:avLst/>
-          </a:prstGeom>
-          <a:noFill/>
-        </p:spPr>
-        <p:txBody>
-          <a:bodyPr wrap="square" anchor="t">
-            <a:spAutoFit/>
-          </a:bodyPr>
-          <a:lstStyle/>
-          <a:p>
-            <a:pPr>
-              <a:spcAft>
-                <a:spcPts val="1000"/>
-              </a:spcAft>
-              <a:defRPr sz="1800">
-                <a:solidFill>
-                  <a:srgbClr val="1E293B"/>
-                </a:solidFill>
-              </a:defRPr>
-            </a:pPr>
-            <a:r>
-              <a:t>llm_models.yaml:</a:t>
-            </a:r>
-          </a:p>
-          <a:p>
-            <a:pPr>
-              <a:spcAft>
-                <a:spcPts val="1000"/>
-              </a:spcAft>
-              <a:defRPr sz="1800">
-                <a:solidFill>
-                  <a:srgbClr val="1E293B"/>
-                </a:solidFill>
-              </a:defRPr>
-            </a:pPr>
-            <a:r>
-              <a:t>  indexing.chat_model: qwen7        → Ollama (summaries/abstract)</a:t>
-            </a:r>
-          </a:p>
-          <a:p>
-            <a:pPr>
-              <a:spcAft>
-                <a:spcPts val="1000"/>
-              </a:spcAft>
-              <a:defRPr sz="1800">
-                <a:solidFill>
-                  <a:srgbClr val="1E293B"/>
-                </a:solidFill>
-              </a:defRPr>
-            </a:pPr>
-            <a:r>
-              <a:t>  indexing.embed_model: mxbai-embed-large</a:t>
-            </a:r>
-          </a:p>
-          <a:p>
-            <a:pPr>
-              <a:spcAft>
-                <a:spcPts val="1000"/>
-              </a:spcAft>
-              <a:defRPr sz="1800">
-                <a:solidFill>
-                  <a:srgbClr val="1E293B"/>
-                </a:solidFill>
-              </a:defRPr>
-            </a:pPr>
-            <a:r>
-              <a:t>  rag.chat_model: gpt51             → OpenAI (needs CHATGPT_API_KEY)</a:t>
-            </a:r>
-          </a:p>
-          <a:p>
-            <a:pPr>
-              <a:spcAft>
-                <a:spcPts val="1000"/>
-              </a:spcAft>
-              <a:defRPr sz="1800">
-                <a:solidFill>
-                  <a:srgbClr val="1E293B"/>
-                </a:solidFill>
-              </a:defRPr>
-            </a:pPr>
-            <a:r>
-              <a:t>  rag.tree_search_model: gpt51</a:t>
-            </a:r>
-          </a:p>
-          <a:p>
-            <a:pPr>
-              <a:spcAft>
-                <a:spcPts val="1000"/>
-              </a:spcAft>
-              <a:defRPr sz="1800">
-                <a:solidFill>
-                  <a:srgbClr val="1E293B"/>
-                </a:solidFill>
-              </a:defRPr>
-            </a:pPr>
-            <a:r>
-              <a:t>  rag.keyword_embed_model: mxbai-embed-large → Ollama</a:t>
-            </a:r>
-          </a:p>
-          <a:p>
-            <a:pPr>
-              <a:spcAft>
-                <a:spcPts val="1000"/>
-              </a:spcAft>
-              <a:defRPr sz="1800">
-                <a:solidFill>
-                  <a:srgbClr val="1E293B"/>
-                </a:solidFill>
-              </a:defRPr>
-            </a:pPr>
-            <a:r>
-              <a:t>Embeddings ALWAYS use local Ollama — even when RAG chat uses OpenAI</a:t>
-            </a:r>
-          </a:p>
-          <a:p>
-            <a:pPr>
-              <a:spcAft>
-                <a:spcPts val="1000"/>
-              </a:spcAft>
-              <a:defRPr sz="1800">
-                <a:solidFill>
-                  <a:srgbClr val="1E293B"/>
-                </a:solidFill>
-              </a:defRPr>
-            </a:pPr>
-            <a:r>
-              <a:t>Fully local option: set all rag.* models to qwen7 in llm_models.yaml</a:t>
             </a:r>
           </a:p>
         </p:txBody>
@@ -3981,7 +3972,7 @@
               </a:defRPr>
             </a:pPr>
             <a:r>
-              <a:t>Model Routing (Automatic)</a:t>
+              <a:t>Current Default Setup (Hybrid)</a:t>
             </a:r>
           </a:p>
         </p:txBody>
@@ -4019,82 +4010,112 @@
               </a:defRPr>
             </a:pPr>
             <a:r>
-              <a:t>qwen7, llama8, ollama …  → Ollama at OLLAMA_BASE_URL</a:t>
-            </a:r>
-          </a:p>
-          <a:p>
-            <a:pPr>
-              <a:spcAft>
-                <a:spcPts val="1000"/>
-              </a:spcAft>
-              <a:defRPr sz="1800">
-                <a:solidFill>
-                  <a:srgbClr val="1E293B"/>
-                </a:solidFill>
-              </a:defRPr>
-            </a:pPr>
-            <a:r>
-              <a:t>gpt51, gpt4mini, gpt4 …  → OpenAI via CHATGPT_API_KEY in .env</a:t>
-            </a:r>
-          </a:p>
-          <a:p>
-            <a:pPr>
-              <a:spcAft>
-                <a:spcPts val="1000"/>
-              </a:spcAft>
-              <a:defRPr sz="1800">
-                <a:solidFill>
-                  <a:srgbClr val="1E293B"/>
-                </a:solidFill>
-              </a:defRPr>
-            </a:pPr>
-            <a:r>
-              <a:t>huggingface              → HF_TOKEN in .env</a:t>
-            </a:r>
-          </a:p>
-          <a:p>
-            <a:pPr>
-              <a:spcAft>
-                <a:spcPts val="1000"/>
-              </a:spcAft>
-              <a:defRPr sz="1800">
-                <a:solidFill>
-                  <a:srgbClr val="1E293B"/>
-                </a:solidFill>
-              </a:defRPr>
-            </a:pPr>
-            <a:r>
-              <a:t>mxbai-embed-large        → Ollama (always)</a:t>
-            </a:r>
-          </a:p>
-          <a:p>
-            <a:pPr>
-              <a:spcAft>
-                <a:spcPts val="1000"/>
-              </a:spcAft>
-              <a:defRPr sz="1800">
-                <a:solidFill>
-                  <a:srgbClr val="1E293B"/>
-                </a:solidFill>
-              </a:defRPr>
-            </a:pPr>
-            <a:r>
-              <a:t>API_PROVIDER env var is NOT used (legacy docs only)</a:t>
-            </a:r>
-          </a:p>
-          <a:p>
-            <a:pPr>
-              <a:spcAft>
-                <a:spcPts val="1000"/>
-              </a:spcAft>
-              <a:defRPr sz="1800">
-                <a:solidFill>
-                  <a:srgbClr val="1E293B"/>
-                </a:solidFill>
-              </a:defRPr>
-            </a:pPr>
-            <a:r>
-              <a:t>Restart Flask apps after changing llm_models.yaml</a:t>
+              <a:t>llm_models.yaml:</a:t>
+            </a:r>
+          </a:p>
+          <a:p>
+            <a:pPr>
+              <a:spcAft>
+                <a:spcPts val="1000"/>
+              </a:spcAft>
+              <a:defRPr sz="1800">
+                <a:solidFill>
+                  <a:srgbClr val="1E293B"/>
+                </a:solidFill>
+              </a:defRPr>
+            </a:pPr>
+            <a:r>
+              <a:t>  indexing.chat_model: qwen7        → Ollama (summaries/abstract)</a:t>
+            </a:r>
+          </a:p>
+          <a:p>
+            <a:pPr>
+              <a:spcAft>
+                <a:spcPts val="1000"/>
+              </a:spcAft>
+              <a:defRPr sz="1800">
+                <a:solidFill>
+                  <a:srgbClr val="1E293B"/>
+                </a:solidFill>
+              </a:defRPr>
+            </a:pPr>
+            <a:r>
+              <a:t>  indexing.embed_model: mxbai-embed-large</a:t>
+            </a:r>
+          </a:p>
+          <a:p>
+            <a:pPr>
+              <a:spcAft>
+                <a:spcPts val="1000"/>
+              </a:spcAft>
+              <a:defRPr sz="1800">
+                <a:solidFill>
+                  <a:srgbClr val="1E293B"/>
+                </a:solidFill>
+              </a:defRPr>
+            </a:pPr>
+            <a:r>
+              <a:t>  rag.chat_model: gpt51             → OpenAI (needs CHATGPT_API_KEY)</a:t>
+            </a:r>
+          </a:p>
+          <a:p>
+            <a:pPr>
+              <a:spcAft>
+                <a:spcPts val="1000"/>
+              </a:spcAft>
+              <a:defRPr sz="1800">
+                <a:solidFill>
+                  <a:srgbClr val="1E293B"/>
+                </a:solidFill>
+              </a:defRPr>
+            </a:pPr>
+            <a:r>
+              <a:t>  rag.tree_search_model: gpt51</a:t>
+            </a:r>
+          </a:p>
+          <a:p>
+            <a:pPr>
+              <a:spcAft>
+                <a:spcPts val="1000"/>
+              </a:spcAft>
+              <a:defRPr sz="1800">
+                <a:solidFill>
+                  <a:srgbClr val="1E293B"/>
+                </a:solidFill>
+              </a:defRPr>
+            </a:pPr>
+            <a:r>
+              <a:t>  rag.keyword_embed_model: mxbai-embed-large → Ollama</a:t>
+            </a:r>
+          </a:p>
+          <a:p>
+            <a:pPr>
+              <a:spcAft>
+                <a:spcPts val="1000"/>
+              </a:spcAft>
+              <a:defRPr sz="1800">
+                <a:solidFill>
+                  <a:srgbClr val="1E293B"/>
+                </a:solidFill>
+              </a:defRPr>
+            </a:pPr>
+            <a:r>
+              <a:t>Embeddings ALWAYS use local Ollama — even when RAG chat uses OpenAI</a:t>
+            </a:r>
+          </a:p>
+          <a:p>
+            <a:pPr>
+              <a:spcAft>
+                <a:spcPts val="1000"/>
+              </a:spcAft>
+              <a:defRPr sz="1800">
+                <a:solidFill>
+                  <a:srgbClr val="1E293B"/>
+                </a:solidFill>
+              </a:defRPr>
+            </a:pPr>
+            <a:r>
+              <a:t>Fully local option: set all rag.* models to qwen7 in llm_models.yaml</a:t>
             </a:r>
           </a:p>
         </p:txBody>
@@ -4108,6 +4129,223 @@
 </file>
 
 <file path=ppt/slides/slide14.xml><?xml version="1.0" encoding="utf-8"?>
+<p:sld xmlns:a="http://schemas.openxmlformats.org/drawingml/2006/main" xmlns:p="http://schemas.openxmlformats.org/presentationml/2006/main" xmlns:r="http://schemas.openxmlformats.org/officeDocument/2006/relationships">
+  <p:cSld>
+    <p:bg>
+      <p:bgPr>
+        <a:solidFill>
+          <a:srgbClr val="FFFFFF"/>
+        </a:solidFill>
+        <a:effectLst/>
+      </p:bgPr>
+    </p:bg>
+    <p:spTree>
+      <p:nvGrpSpPr>
+        <p:cNvPr id="1" name=""/>
+        <p:cNvGrpSpPr/>
+        <p:nvPr/>
+      </p:nvGrpSpPr>
+      <p:grpSpPr/>
+      <p:sp>
+        <p:nvSpPr>
+          <p:cNvPr id="2" name="Rectangle 1"/>
+          <p:cNvSpPr/>
+          <p:nvPr/>
+        </p:nvSpPr>
+        <p:spPr>
+          <a:xfrm>
+            <a:off x="0" y="0"/>
+            <a:ext cx="9144000" cy="822960"/>
+          </a:xfrm>
+          <a:prstGeom prst="rect">
+            <a:avLst/>
+          </a:prstGeom>
+          <a:solidFill>
+            <a:srgbClr val="0D9488"/>
+          </a:solidFill>
+          <a:ln>
+            <a:noFill/>
+          </a:ln>
+        </p:spPr>
+        <p:style>
+          <a:lnRef idx="1">
+            <a:schemeClr val="accent1"/>
+          </a:lnRef>
+          <a:fillRef idx="3">
+            <a:schemeClr val="accent1"/>
+          </a:fillRef>
+          <a:effectRef idx="2">
+            <a:schemeClr val="accent1"/>
+          </a:effectRef>
+          <a:fontRef idx="minor">
+            <a:schemeClr val="lt1"/>
+          </a:fontRef>
+        </p:style>
+        <p:txBody>
+          <a:bodyPr rtlCol="0" anchor="ctr"/>
+          <a:lstStyle/>
+          <a:p>
+            <a:pPr algn="ctr"/>
+          </a:p>
+        </p:txBody>
+      </p:sp>
+      <p:sp>
+        <p:nvSpPr>
+          <p:cNvPr id="3" name="TextBox 2"/>
+          <p:cNvSpPr txBox="1"/>
+          <p:nvPr/>
+        </p:nvSpPr>
+        <p:spPr>
+          <a:xfrm>
+            <a:off x="457200" y="137160"/>
+            <a:ext cx="8229600" cy="640080"/>
+          </a:xfrm>
+          <a:prstGeom prst="rect">
+            <a:avLst/>
+          </a:prstGeom>
+          <a:noFill/>
+        </p:spPr>
+        <p:txBody>
+          <a:bodyPr wrap="none">
+            <a:spAutoFit/>
+          </a:bodyPr>
+          <a:lstStyle/>
+          <a:p>
+            <a:pPr>
+              <a:defRPr sz="2800" b="1">
+                <a:solidFill>
+                  <a:srgbClr val="FFFFFF"/>
+                </a:solidFill>
+              </a:defRPr>
+            </a:pPr>
+            <a:r>
+              <a:t>Model Routing (Automatic)</a:t>
+            </a:r>
+          </a:p>
+        </p:txBody>
+      </p:sp>
+      <p:sp>
+        <p:nvSpPr>
+          <p:cNvPr id="4" name="TextBox 3"/>
+          <p:cNvSpPr txBox="1"/>
+          <p:nvPr/>
+        </p:nvSpPr>
+        <p:spPr>
+          <a:xfrm>
+            <a:off x="502920" y="1051560"/>
+            <a:ext cx="8229600" cy="5303520"/>
+          </a:xfrm>
+          <a:prstGeom prst="rect">
+            <a:avLst/>
+          </a:prstGeom>
+          <a:noFill/>
+        </p:spPr>
+        <p:txBody>
+          <a:bodyPr wrap="square" anchor="t">
+            <a:spAutoFit/>
+          </a:bodyPr>
+          <a:lstStyle/>
+          <a:p>
+            <a:pPr>
+              <a:spcAft>
+                <a:spcPts val="1000"/>
+              </a:spcAft>
+              <a:defRPr sz="1800">
+                <a:solidFill>
+                  <a:srgbClr val="1E293B"/>
+                </a:solidFill>
+              </a:defRPr>
+            </a:pPr>
+            <a:r>
+              <a:t>qwen7, llama8, ollama …  → Ollama at OLLAMA_BASE_URL</a:t>
+            </a:r>
+          </a:p>
+          <a:p>
+            <a:pPr>
+              <a:spcAft>
+                <a:spcPts val="1000"/>
+              </a:spcAft>
+              <a:defRPr sz="1800">
+                <a:solidFill>
+                  <a:srgbClr val="1E293B"/>
+                </a:solidFill>
+              </a:defRPr>
+            </a:pPr>
+            <a:r>
+              <a:t>gpt51, gpt4mini, gpt4 …  → OpenAI via CHATGPT_API_KEY in .env</a:t>
+            </a:r>
+          </a:p>
+          <a:p>
+            <a:pPr>
+              <a:spcAft>
+                <a:spcPts val="1000"/>
+              </a:spcAft>
+              <a:defRPr sz="1800">
+                <a:solidFill>
+                  <a:srgbClr val="1E293B"/>
+                </a:solidFill>
+              </a:defRPr>
+            </a:pPr>
+            <a:r>
+              <a:t>huggingface              → HF_TOKEN in .env</a:t>
+            </a:r>
+          </a:p>
+          <a:p>
+            <a:pPr>
+              <a:spcAft>
+                <a:spcPts val="1000"/>
+              </a:spcAft>
+              <a:defRPr sz="1800">
+                <a:solidFill>
+                  <a:srgbClr val="1E293B"/>
+                </a:solidFill>
+              </a:defRPr>
+            </a:pPr>
+            <a:r>
+              <a:t>mxbai-embed-large        → Ollama (always)</a:t>
+            </a:r>
+          </a:p>
+          <a:p>
+            <a:pPr>
+              <a:spcAft>
+                <a:spcPts val="1000"/>
+              </a:spcAft>
+              <a:defRPr sz="1800">
+                <a:solidFill>
+                  <a:srgbClr val="1E293B"/>
+                </a:solidFill>
+              </a:defRPr>
+            </a:pPr>
+            <a:r>
+              <a:t>API_PROVIDER env var is NOT used (legacy docs only)</a:t>
+            </a:r>
+          </a:p>
+          <a:p>
+            <a:pPr>
+              <a:spcAft>
+                <a:spcPts val="1000"/>
+              </a:spcAft>
+              <a:defRPr sz="1800">
+                <a:solidFill>
+                  <a:srgbClr val="1E293B"/>
+                </a:solidFill>
+              </a:defRPr>
+            </a:pPr>
+            <a:r>
+              <a:t>Restart Flask apps after changing llm_models.yaml</a:t>
+            </a:r>
+          </a:p>
+        </p:txBody>
+      </p:sp>
+    </p:spTree>
+  </p:cSld>
+  <p:clrMapOvr>
+    <a:masterClrMapping/>
+  </p:clrMapOvr>
+</p:sld>
+</file>
+
+<file path=ppt/slides/slide15.xml><?xml version="1.0" encoding="utf-8"?>
 <p:sld xmlns:a="http://schemas.openxmlformats.org/drawingml/2006/main" xmlns:p="http://schemas.openxmlformats.org/presentationml/2006/main" xmlns:r="http://schemas.openxmlformats.org/officeDocument/2006/relationships">
   <p:cSld>
     <p:bg>
@@ -4156,223 +4394,6 @@
             </a:pPr>
             <a:r>
               <a:t>Getting Started</a:t>
-            </a:r>
-          </a:p>
-        </p:txBody>
-      </p:sp>
-    </p:spTree>
-  </p:cSld>
-  <p:clrMapOvr>
-    <a:masterClrMapping/>
-  </p:clrMapOvr>
-</p:sld>
-</file>
-
-<file path=ppt/slides/slide15.xml><?xml version="1.0" encoding="utf-8"?>
-<p:sld xmlns:a="http://schemas.openxmlformats.org/drawingml/2006/main" xmlns:p="http://schemas.openxmlformats.org/presentationml/2006/main" xmlns:r="http://schemas.openxmlformats.org/officeDocument/2006/relationships">
-  <p:cSld>
-    <p:bg>
-      <p:bgPr>
-        <a:solidFill>
-          <a:srgbClr val="FFFFFF"/>
-        </a:solidFill>
-        <a:effectLst/>
-      </p:bgPr>
-    </p:bg>
-    <p:spTree>
-      <p:nvGrpSpPr>
-        <p:cNvPr id="1" name=""/>
-        <p:cNvGrpSpPr/>
-        <p:nvPr/>
-      </p:nvGrpSpPr>
-      <p:grpSpPr/>
-      <p:sp>
-        <p:nvSpPr>
-          <p:cNvPr id="2" name="Rectangle 1"/>
-          <p:cNvSpPr/>
-          <p:nvPr/>
-        </p:nvSpPr>
-        <p:spPr>
-          <a:xfrm>
-            <a:off x="0" y="0"/>
-            <a:ext cx="9144000" cy="822960"/>
-          </a:xfrm>
-          <a:prstGeom prst="rect">
-            <a:avLst/>
-          </a:prstGeom>
-          <a:solidFill>
-            <a:srgbClr val="0D9488"/>
-          </a:solidFill>
-          <a:ln>
-            <a:noFill/>
-          </a:ln>
-        </p:spPr>
-        <p:style>
-          <a:lnRef idx="1">
-            <a:schemeClr val="accent1"/>
-          </a:lnRef>
-          <a:fillRef idx="3">
-            <a:schemeClr val="accent1"/>
-          </a:fillRef>
-          <a:effectRef idx="2">
-            <a:schemeClr val="accent1"/>
-          </a:effectRef>
-          <a:fontRef idx="minor">
-            <a:schemeClr val="lt1"/>
-          </a:fontRef>
-        </p:style>
-        <p:txBody>
-          <a:bodyPr rtlCol="0" anchor="ctr"/>
-          <a:lstStyle/>
-          <a:p>
-            <a:pPr algn="ctr"/>
-          </a:p>
-        </p:txBody>
-      </p:sp>
-      <p:sp>
-        <p:nvSpPr>
-          <p:cNvPr id="3" name="TextBox 2"/>
-          <p:cNvSpPr txBox="1"/>
-          <p:nvPr/>
-        </p:nvSpPr>
-        <p:spPr>
-          <a:xfrm>
-            <a:off x="457200" y="137160"/>
-            <a:ext cx="8229600" cy="640080"/>
-          </a:xfrm>
-          <a:prstGeom prst="rect">
-            <a:avLst/>
-          </a:prstGeom>
-          <a:noFill/>
-        </p:spPr>
-        <p:txBody>
-          <a:bodyPr wrap="none">
-            <a:spAutoFit/>
-          </a:bodyPr>
-          <a:lstStyle/>
-          <a:p>
-            <a:pPr>
-              <a:defRPr sz="2800" b="1">
-                <a:solidFill>
-                  <a:srgbClr val="FFFFFF"/>
-                </a:solidFill>
-              </a:defRPr>
-            </a:pPr>
-            <a:r>
-              <a:t>New Maintainer — 5 Steps</a:t>
-            </a:r>
-          </a:p>
-        </p:txBody>
-      </p:sp>
-      <p:sp>
-        <p:nvSpPr>
-          <p:cNvPr id="4" name="TextBox 3"/>
-          <p:cNvSpPr txBox="1"/>
-          <p:nvPr/>
-        </p:nvSpPr>
-        <p:spPr>
-          <a:xfrm>
-            <a:off x="502920" y="1051560"/>
-            <a:ext cx="8229600" cy="5303520"/>
-          </a:xfrm>
-          <a:prstGeom prst="rect">
-            <a:avLst/>
-          </a:prstGeom>
-          <a:noFill/>
-        </p:spPr>
-        <p:txBody>
-          <a:bodyPr wrap="square" anchor="t">
-            <a:spAutoFit/>
-          </a:bodyPr>
-          <a:lstStyle/>
-          <a:p>
-            <a:pPr>
-              <a:spcAft>
-                <a:spcPts val="1000"/>
-              </a:spcAft>
-              <a:defRPr sz="1800">
-                <a:solidFill>
-                  <a:srgbClr val="1E293B"/>
-                </a:solidFill>
-              </a:defRPr>
-            </a:pPr>
-            <a:r>
-              <a:t>1. pip install -r requirements.txt  (from project root)</a:t>
-            </a:r>
-          </a:p>
-          <a:p>
-            <a:pPr>
-              <a:spcAft>
-                <a:spcPts val="1000"/>
-              </a:spcAft>
-              <a:defRPr sz="1800">
-                <a:solidFill>
-                  <a:srgbClr val="1E293B"/>
-                </a:solidFill>
-              </a:defRPr>
-            </a:pPr>
-            <a:r>
-              <a:t>2. cp .env.example .env → set CHATGPT_API_KEY (for gpt51 RAG)</a:t>
-            </a:r>
-          </a:p>
-          <a:p>
-            <a:pPr>
-              <a:spcAft>
-                <a:spcPts val="1000"/>
-              </a:spcAft>
-              <a:defRPr sz="1800">
-                <a:solidFill>
-                  <a:srgbClr val="1E293B"/>
-                </a:solidFill>
-              </a:defRPr>
-            </a:pPr>
-            <a:r>
-              <a:t>3. ollama serve; ollama pull mxbai-embed-large; ollama pull qwen2.5:7b</a:t>
-            </a:r>
-          </a:p>
-          <a:p>
-            <a:pPr>
-              <a:spcAft>
-                <a:spcPts val="1000"/>
-              </a:spcAft>
-              <a:defRPr sz="1800">
-                <a:solidFill>
-                  <a:srgbClr val="1E293B"/>
-                </a:solidFill>
-              </a:defRPr>
-            </a:pPr>
-            <a:r>
-              <a:t>4. Put PDFs in Database/ → python build_docindex.py</a:t>
-            </a:r>
-          </a:p>
-          <a:p>
-            <a:pPr>
-              <a:spcAft>
-                <a:spcPts val="1000"/>
-              </a:spcAft>
-              <a:defRPr sz="1800">
-                <a:solidFill>
-                  <a:srgbClr val="1E293B"/>
-                </a:solidFill>
-              </a:defRPr>
-            </a:pPr>
-            <a:r>
-              <a:t>5. python RAG-Interface/app.py  OR  python RAG/rag_query.py --query "…"</a:t>
-            </a:r>
-          </a:p>
-          <a:p>
-            <a:pPr>
-              <a:spcAft>
-                <a:spcPts val="1000"/>
-              </a:spcAft>
-              <a:defRPr sz="1800">
-                <a:solidFill>
-                  <a:srgbClr val="1E293B"/>
-                </a:solidFill>
-              </a:defRPr>
-            </a:pPr>
-            <a:r>
-              <a:t>Always run commands from the PageIndex/ project root</a:t>
             </a:r>
           </a:p>
         </p:txBody>
@@ -4476,7 +4497,7 @@
               </a:defRPr>
             </a:pPr>
             <a:r>
-              <a:t>Day-to-Day Operations</a:t>
+              <a:t>New Maintainer — 5 Steps</a:t>
             </a:r>
           </a:p>
         </p:txBody>
@@ -4514,82 +4535,82 @@
               </a:defRPr>
             </a:pPr>
             <a:r>
-              <a:t>Add PDF: copy to Database/ → python build_docindex.py (or single-file run_pageindex.py)</a:t>
-            </a:r>
-          </a:p>
-          <a:p>
-            <a:pPr>
-              <a:spcAft>
-                <a:spcPts val="1000"/>
-              </a:spcAft>
-              <a:defRPr sz="1800">
-                <a:solidFill>
-                  <a:srgbClr val="1E293B"/>
-                </a:solidFill>
-              </a:defRPr>
-            </a:pPr>
-            <a:r>
-              <a:t>Re-index after config changes: re-run indexing for affected PDFs</a:t>
-            </a:r>
-          </a:p>
-          <a:p>
-            <a:pPr>
-              <a:spcAft>
-                <a:spcPts val="1000"/>
-              </a:spcAft>
-              <a:defRPr sz="1800">
-                <a:solidFill>
-                  <a:srgbClr val="1E293B"/>
-                </a:solidFill>
-              </a:defRPr>
-            </a:pPr>
-            <a:r>
-              <a:t>Change answer model: edit rag.* in llm_models.yaml → restart chat UI</a:t>
-            </a:r>
-          </a:p>
-          <a:p>
-            <a:pPr>
-              <a:spcAft>
-                <a:spcPts val="1000"/>
-              </a:spcAft>
-              <a:defRPr sz="1800">
-                <a:solidFill>
-                  <a:srgbClr val="1E293B"/>
-                </a:solidFill>
-              </a:defRPr>
-            </a:pPr>
-            <a:r>
-              <a:t>Customize answers: edit prompts in RAG/utils.py</a:t>
-            </a:r>
-          </a:p>
-          <a:p>
-            <a:pPr>
-              <a:spcAft>
-                <a:spcPts val="1000"/>
-              </a:spcAft>
-              <a:defRPr sz="1800">
-                <a:solidFill>
-                  <a:srgbClr val="1E293B"/>
-                </a:solidFill>
-              </a:defRPr>
-            </a:pPr>
-            <a:r>
-              <a:t>  generate_answer_with_citations(), combine_answers(), tree_search()</a:t>
-            </a:r>
-          </a:p>
-          <a:p>
-            <a:pPr>
-              <a:spcAft>
-                <a:spcPts val="1000"/>
-              </a:spcAft>
-              <a:defRPr sz="1800">
-                <a:solidFill>
-                  <a:srgbClr val="1E293B"/>
-                </a:solidFill>
-              </a:defRPr>
-            </a:pPr>
-            <a:r>
-              <a:t>Logs: logs/ (indexing)  |  terminal output (RAG UI)</a:t>
+              <a:t>1. pip install -r requirements.txt  (from project root)</a:t>
+            </a:r>
+          </a:p>
+          <a:p>
+            <a:pPr>
+              <a:spcAft>
+                <a:spcPts val="1000"/>
+              </a:spcAft>
+              <a:defRPr sz="1800">
+                <a:solidFill>
+                  <a:srgbClr val="1E293B"/>
+                </a:solidFill>
+              </a:defRPr>
+            </a:pPr>
+            <a:r>
+              <a:t>2. cp .env.example .env → set CHATGPT_API_KEY (for gpt51 RAG)</a:t>
+            </a:r>
+          </a:p>
+          <a:p>
+            <a:pPr>
+              <a:spcAft>
+                <a:spcPts val="1000"/>
+              </a:spcAft>
+              <a:defRPr sz="1800">
+                <a:solidFill>
+                  <a:srgbClr val="1E293B"/>
+                </a:solidFill>
+              </a:defRPr>
+            </a:pPr>
+            <a:r>
+              <a:t>3. ollama serve; ollama pull mxbai-embed-large; ollama pull qwen2.5:7b</a:t>
+            </a:r>
+          </a:p>
+          <a:p>
+            <a:pPr>
+              <a:spcAft>
+                <a:spcPts val="1000"/>
+              </a:spcAft>
+              <a:defRPr sz="1800">
+                <a:solidFill>
+                  <a:srgbClr val="1E293B"/>
+                </a:solidFill>
+              </a:defRPr>
+            </a:pPr>
+            <a:r>
+              <a:t>4. Put PDFs in Database/ → python build_docindex.py</a:t>
+            </a:r>
+          </a:p>
+          <a:p>
+            <a:pPr>
+              <a:spcAft>
+                <a:spcPts val="1000"/>
+              </a:spcAft>
+              <a:defRPr sz="1800">
+                <a:solidFill>
+                  <a:srgbClr val="1E293B"/>
+                </a:solidFill>
+              </a:defRPr>
+            </a:pPr>
+            <a:r>
+              <a:t>5. python RAG-Interface/app.py  OR  python RAG/rag_query.py --query "…"</a:t>
+            </a:r>
+          </a:p>
+          <a:p>
+            <a:pPr>
+              <a:spcAft>
+                <a:spcPts val="1000"/>
+              </a:spcAft>
+              <a:defRPr sz="1800">
+                <a:solidFill>
+                  <a:srgbClr val="1E293B"/>
+                </a:solidFill>
+              </a:defRPr>
+            </a:pPr>
+            <a:r>
+              <a:t>Always run commands from the PageIndex/ project root</a:t>
             </a:r>
           </a:p>
         </p:txBody>
@@ -4693,7 +4714,7 @@
               </a:defRPr>
             </a:pPr>
             <a:r>
-              <a:t>Troubleshooting</a:t>
+              <a:t>Day-to-Day Operations</a:t>
             </a:r>
           </a:p>
         </p:txBody>
@@ -4731,97 +4752,97 @@
               </a:defRPr>
             </a:pPr>
             <a:r>
-              <a:t>No DocIndex found → run build_docindex.py from project root</a:t>
-            </a:r>
-          </a:p>
-          <a:p>
-            <a:pPr>
-              <a:spcAft>
-                <a:spcPts val="1000"/>
-              </a:spcAft>
-              <a:defRPr sz="1800">
-                <a:solidFill>
-                  <a:srgbClr val="1E293B"/>
-                </a:solidFill>
-              </a:defRPr>
-            </a:pPr>
-            <a:r>
-              <a:t>Ollama / embedding errors → ollama serve; pull mxbai-embed-large</a:t>
-            </a:r>
-          </a:p>
-          <a:p>
-            <a:pPr>
-              <a:spcAft>
-                <a:spcPts val="1000"/>
-              </a:spcAft>
-              <a:defRPr sz="1800">
-                <a:solidFill>
-                  <a:srgbClr val="1E293B"/>
-                </a:solidFill>
-              </a:defRPr>
-            </a:pPr>
-            <a:r>
-              <a:t>OpenAI errors → check CHATGPT_API_KEY for gpt* aliases</a:t>
-            </a:r>
-          </a:p>
-          <a:p>
-            <a:pPr>
-              <a:spcAft>
-                <a:spcPts val="1000"/>
-              </a:spcAft>
-              <a:defRPr sz="1800">
-                <a:solidFill>
-                  <a:srgbClr val="1E293B"/>
-                </a:solidFill>
-              </a:defRPr>
-            </a:pPr>
-            <a:r>
-              <a:t>No matching documents → re-index; lower keyword-match threshold</a:t>
-            </a:r>
-          </a:p>
-          <a:p>
-            <a:pPr>
-              <a:spcAft>
-                <a:spcPts val="1000"/>
-              </a:spcAft>
-              <a:defRPr sz="1800">
-                <a:solidFill>
-                  <a:srgbClr val="1E293B"/>
-                </a:solidFill>
-              </a:defRPr>
-            </a:pPr>
-            <a:r>
-              <a:t>Wrong results/ cache path → always cd to project root first</a:t>
-            </a:r>
-          </a:p>
-          <a:p>
-            <a:pPr>
-              <a:spcAft>
-                <a:spcPts val="1000"/>
-              </a:spcAft>
-              <a:defRPr sz="1800">
-                <a:solidFill>
-                  <a:srgbClr val="1E293B"/>
-                </a:solidFill>
-              </a:defRPr>
-            </a:pPr>
-            <a:r>
-              <a:t>GPU driver mismatch → reboot after NVIDIA driver updates</a:t>
-            </a:r>
-          </a:p>
-          <a:p>
-            <a:pPr>
-              <a:spcAft>
-                <a:spcPts val="1000"/>
-              </a:spcAft>
-              <a:defRPr sz="1800">
-                <a:solidFill>
-                  <a:srgbClr val="1E293B"/>
-                </a:solidFill>
-              </a:defRPr>
-            </a:pPr>
-            <a:r>
-              <a:t>Empty doc_authors → re-index PDF (author extraction was improved)</a:t>
+              <a:t>Add PDF: upload in DocIndex UI or copy to Database/ → index</a:t>
+            </a:r>
+          </a:p>
+          <a:p>
+            <a:pPr>
+              <a:spcAft>
+                <a:spcPts val="1000"/>
+              </a:spcAft>
+              <a:defRPr sz="1800">
+                <a:solidFill>
+                  <a:srgbClr val="1E293B"/>
+                </a:solidFill>
+              </a:defRPr>
+            </a:pPr>
+            <a:r>
+              <a:t>Remove PDF: Remove button in DocIndex UI (cleans all artifacts)</a:t>
+            </a:r>
+          </a:p>
+          <a:p>
+            <a:pPr>
+              <a:spcAft>
+                <a:spcPts val="1000"/>
+              </a:spcAft>
+              <a:defRPr sz="1800">
+                <a:solidFill>
+                  <a:srgbClr val="1E293B"/>
+                </a:solidFill>
+              </a:defRPr>
+            </a:pPr>
+            <a:r>
+              <a:t>Re-index: Update Structure (one file) or DocIndex Reconstruction (all)</a:t>
+            </a:r>
+          </a:p>
+          <a:p>
+            <a:pPr>
+              <a:spcAft>
+                <a:spcPts val="1000"/>
+              </a:spcAft>
+              <a:defRPr sz="1800">
+                <a:solidFill>
+                  <a:srgbClr val="1E293B"/>
+                </a:solidFill>
+              </a:defRPr>
+            </a:pPr>
+            <a:r>
+              <a:t>Change answer model: edit rag.* in llm_models.yaml → restart chat UI</a:t>
+            </a:r>
+          </a:p>
+          <a:p>
+            <a:pPr>
+              <a:spcAft>
+                <a:spcPts val="1000"/>
+              </a:spcAft>
+              <a:defRPr sz="1800">
+                <a:solidFill>
+                  <a:srgbClr val="1E293B"/>
+                </a:solidFill>
+              </a:defRPr>
+            </a:pPr>
+            <a:r>
+              <a:t>Customize prompts: RAG/utils.py (answers, tree search, history helpers)</a:t>
+            </a:r>
+          </a:p>
+          <a:p>
+            <a:pPr>
+              <a:spcAft>
+                <a:spcPts val="1000"/>
+              </a:spcAft>
+              <a:defRPr sz="1800">
+                <a:solidFill>
+                  <a:srgbClr val="1E293B"/>
+                </a:solidFill>
+              </a:defRPr>
+            </a:pPr>
+            <a:r>
+              <a:t>After git pull: restart Flask apps so new API routes load</a:t>
+            </a:r>
+          </a:p>
+          <a:p>
+            <a:pPr>
+              <a:spcAft>
+                <a:spcPts val="1000"/>
+              </a:spcAft>
+              <a:defRPr sz="1800">
+                <a:solidFill>
+                  <a:srgbClr val="1E293B"/>
+                </a:solidFill>
+              </a:defRPr>
+            </a:pPr>
+            <a:r>
+              <a:t>Logs: logs/ (indexing) | terminal output (web UIs)</a:t>
             </a:r>
           </a:p>
         </p:txBody>
@@ -4925,7 +4946,7 @@
               </a:defRPr>
             </a:pPr>
             <a:r>
-              <a:t>Evaluation &amp; Documentation</a:t>
+              <a:t>Troubleshooting</a:t>
             </a:r>
           </a:p>
         </p:txBody>
@@ -4963,97 +4984,97 @@
               </a:defRPr>
             </a:pPr>
             <a:r>
-              <a:t>README.md — full setup, reference, troubleshooting</a:t>
-            </a:r>
-          </a:p>
-          <a:p>
-            <a:pPr>
-              <a:spcAft>
-                <a:spcPts val="1000"/>
-              </a:spcAft>
-              <a:defRPr sz="1800">
-                <a:solidFill>
-                  <a:srgbClr val="1E293B"/>
-                </a:solidFill>
-              </a:defRPr>
-            </a:pPr>
-            <a:r>
-              <a:t>docs/PageIndex_Handoff.pptx — handoff slide deck</a:t>
-            </a:r>
-          </a:p>
-          <a:p>
-            <a:pPr>
-              <a:spcAft>
-                <a:spcPts val="1000"/>
-              </a:spcAft>
-              <a:defRPr sz="1800">
-                <a:solidFill>
-                  <a:srgbClr val="1E293B"/>
-                </a:solidFill>
-              </a:defRPr>
-            </a:pPr>
-            <a:r>
-              <a:t>.env.example — secrets template</a:t>
-            </a:r>
-          </a:p>
-          <a:p>
-            <a:pPr>
-              <a:spcAft>
-                <a:spcPts val="1000"/>
-              </a:spcAft>
-              <a:defRPr sz="1800">
-                <a:solidFill>
-                  <a:srgbClr val="1E293B"/>
-                </a:solidFill>
-              </a:defRPr>
-            </a:pPr>
-            <a:r>
-              <a:t>OLLAMA_SETUP.md — Ollama install guide</a:t>
-            </a:r>
-          </a:p>
-          <a:p>
-            <a:pPr>
-              <a:spcAft>
-                <a:spcPts val="1000"/>
-              </a:spcAft>
-              <a:defRPr sz="1800">
-                <a:solidFill>
-                  <a:srgbClr val="1E293B"/>
-                </a:solidFill>
-              </a:defRPr>
-            </a:pPr>
-            <a:r>
-              <a:t>benchmarks/run_benchmarks.py — timing harness</a:t>
-            </a:r>
-          </a:p>
-          <a:p>
-            <a:pPr>
-              <a:spcAft>
-                <a:spcPts val="1000"/>
-              </a:spcAft>
-              <a:defRPr sz="1800">
-                <a:solidFill>
-                  <a:srgbClr val="1E293B"/>
-                </a:solidFill>
-              </a:defRPr>
-            </a:pPr>
-            <a:r>
-              <a:t>eval/ragas_eval.py — answer quality (needs OPENAI_API_KEY for judge)</a:t>
-            </a:r>
-          </a:p>
-          <a:p>
-            <a:pPr>
-              <a:spcAft>
-                <a:spcPts val="1000"/>
-              </a:spcAft>
-              <a:defRPr sz="1800">
-                <a:solidFill>
-                  <a:srgbClr val="1E293B"/>
-                </a:solidFill>
-              </a:defRPr>
-            </a:pPr>
-            <a:r>
-              <a:t>cookbook/, tutorials/ — upstream PageIndex reference material</a:t>
+              <a:t>No DocIndex found → run build_docindex.py from project root</a:t>
+            </a:r>
+          </a:p>
+          <a:p>
+            <a:pPr>
+              <a:spcAft>
+                <a:spcPts val="1000"/>
+              </a:spcAft>
+              <a:defRPr sz="1800">
+                <a:solidFill>
+                  <a:srgbClr val="1E293B"/>
+                </a:solidFill>
+              </a:defRPr>
+            </a:pPr>
+            <a:r>
+              <a:t>Ollama / embedding errors → ollama serve; pull mxbai-embed-large</a:t>
+            </a:r>
+          </a:p>
+          <a:p>
+            <a:pPr>
+              <a:spcAft>
+                <a:spcPts val="1000"/>
+              </a:spcAft>
+              <a:defRPr sz="1800">
+                <a:solidFill>
+                  <a:srgbClr val="1E293B"/>
+                </a:solidFill>
+              </a:defRPr>
+            </a:pPr>
+            <a:r>
+              <a:t>OpenAI errors → check CHATGPT_API_KEY for gpt* aliases</a:t>
+            </a:r>
+          </a:p>
+          <a:p>
+            <a:pPr>
+              <a:spcAft>
+                <a:spcPts val="1000"/>
+              </a:spcAft>
+              <a:defRPr sz="1800">
+                <a:solidFill>
+                  <a:srgbClr val="1E293B"/>
+                </a:solidFill>
+              </a:defRPr>
+            </a:pPr>
+            <a:r>
+              <a:t>DocIndex API 404 / JSON parse error → restart Flask server</a:t>
+            </a:r>
+          </a:p>
+          <a:p>
+            <a:pPr>
+              <a:spcAft>
+                <a:spcPts val="1000"/>
+              </a:spcAft>
+              <a:defRPr sz="1800">
+                <a:solidFill>
+                  <a:srgbClr val="1E293B"/>
+                </a:solidFill>
+              </a:defRPr>
+            </a:pPr>
+            <a:r>
+              <a:t>No matching documents → re-index; lower keyword-match threshold</a:t>
+            </a:r>
+          </a:p>
+          <a:p>
+            <a:pPr>
+              <a:spcAft>
+                <a:spcPts val="1000"/>
+              </a:spcAft>
+              <a:defRPr sz="1800">
+                <a:solidFill>
+                  <a:srgbClr val="1E293B"/>
+                </a:solidFill>
+              </a:defRPr>
+            </a:pPr>
+            <a:r>
+              <a:t>Empty doc_authors → re-index PDF (author extraction improved)</a:t>
+            </a:r>
+          </a:p>
+          <a:p>
+            <a:pPr>
+              <a:spcAft>
+                <a:spcPts val="1000"/>
+              </a:spcAft>
+              <a:defRPr sz="1800">
+                <a:solidFill>
+                  <a:srgbClr val="1E293B"/>
+                </a:solidFill>
+              </a:defRPr>
+            </a:pPr>
+            <a:r>
+              <a:t>GPU driver mismatch → reboot after NVIDIA driver updates</a:t>
             </a:r>
           </a:p>
         </p:txBody>
@@ -5157,7 +5178,7 @@
               </a:defRPr>
             </a:pPr>
             <a:r>
-              <a:t>Handoff Checklist</a:t>
+              <a:t>Documentation</a:t>
             </a:r>
           </a:p>
         </p:txBody>
@@ -5195,112 +5216,97 @@
               </a:defRPr>
             </a:pPr>
             <a:r>
-              <a:t>☐ Repo access transferred</a:t>
-            </a:r>
-          </a:p>
-          <a:p>
-            <a:pPr>
-              <a:spcAft>
-                <a:spcPts val="1000"/>
-              </a:spcAft>
-              <a:defRPr sz="1800">
-                <a:solidFill>
-                  <a:srgbClr val="1E293B"/>
-                </a:solidFill>
-              </a:defRPr>
-            </a:pPr>
-            <a:r>
-              <a:t>☐ Python 3.12 environment + requirements installed</a:t>
-            </a:r>
-          </a:p>
-          <a:p>
-            <a:pPr>
-              <a:spcAft>
-                <a:spcPts val="1000"/>
-              </a:spcAft>
-              <a:defRPr sz="1800">
-                <a:solidFill>
-                  <a:srgbClr val="1E293B"/>
-                </a:solidFill>
-              </a:defRPr>
-            </a:pPr>
-            <a:r>
-              <a:t>☐ .env configured (CHATGPT_API_KEY, Ollama URL)</a:t>
-            </a:r>
-          </a:p>
-          <a:p>
-            <a:pPr>
-              <a:spcAft>
-                <a:spcPts val="1000"/>
-              </a:spcAft>
-              <a:defRPr sz="1800">
-                <a:solidFill>
-                  <a:srgbClr val="1E293B"/>
-                </a:solidFill>
-              </a:defRPr>
-            </a:pPr>
-            <a:r>
-              <a:t>☐ Ollama running with mxbai-embed-large + qwen2.5:7b</a:t>
-            </a:r>
-          </a:p>
-          <a:p>
-            <a:pPr>
-              <a:spcAft>
-                <a:spcPts val="1000"/>
-              </a:spcAft>
-              <a:defRPr sz="1800">
-                <a:solidFill>
-                  <a:srgbClr val="1E293B"/>
-                </a:solidFill>
-              </a:defRPr>
-            </a:pPr>
-            <a:r>
-              <a:t>☐ Database/ PDFs present; build_docindex.py completed</a:t>
-            </a:r>
-          </a:p>
-          <a:p>
-            <a:pPr>
-              <a:spcAft>
-                <a:spcPts val="1000"/>
-              </a:spcAft>
-              <a:defRPr sz="1800">
-                <a:solidFill>
-                  <a:srgbClr val="1E293B"/>
-                </a:solidFill>
-              </a:defRPr>
-            </a:pPr>
-            <a:r>
-              <a:t>☐ results/DocIndex.json exists</a:t>
-            </a:r>
-          </a:p>
-          <a:p>
-            <a:pPr>
-              <a:spcAft>
-                <a:spcPts val="1000"/>
-              </a:spcAft>
-              <a:defRPr sz="1800">
-                <a:solidFill>
-                  <a:srgbClr val="1E293B"/>
-                </a:solidFill>
-              </a:defRPr>
-            </a:pPr>
-            <a:r>
-              <a:t>☐ RAG chat smoke test passed (including a follow-up question)</a:t>
-            </a:r>
-          </a:p>
-          <a:p>
-            <a:pPr>
-              <a:spcAft>
-                <a:spcPts val="1000"/>
-              </a:spcAft>
-              <a:defRPr sz="1800">
-                <a:solidFill>
-                  <a:srgbClr val="1E293B"/>
-                </a:solidFill>
-              </a:defRPr>
-            </a:pPr>
-            <a:r>
-              <a:t>☐ README.md reviewed by new maintainer</a:t>
+              <a:t>README.md — full setup, reference, troubleshooting</a:t>
+            </a:r>
+          </a:p>
+          <a:p>
+            <a:pPr>
+              <a:spcAft>
+                <a:spcPts val="1000"/>
+              </a:spcAft>
+              <a:defRPr sz="1800">
+                <a:solidFill>
+                  <a:srgbClr val="1E293B"/>
+                </a:solidFill>
+              </a:defRPr>
+            </a:pPr>
+            <a:r>
+              <a:t>RAG-Interface/README.md — chat UI + conversation history</a:t>
+            </a:r>
+          </a:p>
+          <a:p>
+            <a:pPr>
+              <a:spcAft>
+                <a:spcPts val="1000"/>
+              </a:spcAft>
+              <a:defRPr sz="1800">
+                <a:solidFill>
+                  <a:srgbClr val="1E293B"/>
+                </a:solidFill>
+              </a:defRPr>
+            </a:pPr>
+            <a:r>
+              <a:t>DocIndex-Interface/README.md — upload, index, remove</a:t>
+            </a:r>
+          </a:p>
+          <a:p>
+            <a:pPr>
+              <a:spcAft>
+                <a:spcPts val="1000"/>
+              </a:spcAft>
+              <a:defRPr sz="1800">
+                <a:solidFill>
+                  <a:srgbClr val="1E293B"/>
+                </a:solidFill>
+              </a:defRPr>
+            </a:pPr>
+            <a:r>
+              <a:t>docs/PageIndex_Handoff.pptx — this slide deck</a:t>
+            </a:r>
+          </a:p>
+          <a:p>
+            <a:pPr>
+              <a:spcAft>
+                <a:spcPts val="1000"/>
+              </a:spcAft>
+              <a:defRPr sz="1800">
+                <a:solidFill>
+                  <a:srgbClr val="1E293B"/>
+                </a:solidFill>
+              </a:defRPr>
+            </a:pPr>
+            <a:r>
+              <a:t>.env.example — secrets template</a:t>
+            </a:r>
+          </a:p>
+          <a:p>
+            <a:pPr>
+              <a:spcAft>
+                <a:spcPts val="1000"/>
+              </a:spcAft>
+              <a:defRPr sz="1800">
+                <a:solidFill>
+                  <a:srgbClr val="1E293B"/>
+                </a:solidFill>
+              </a:defRPr>
+            </a:pPr>
+            <a:r>
+              <a:t>scripts/generate_handoff_ppt.py — regenerate deck</a:t>
+            </a:r>
+          </a:p>
+          <a:p>
+            <a:pPr>
+              <a:spcAft>
+                <a:spcPts val="1000"/>
+              </a:spcAft>
+              <a:defRPr sz="1800">
+                <a:solidFill>
+                  <a:srgbClr val="1E293B"/>
+                </a:solidFill>
+              </a:defRPr>
+            </a:pPr>
+            <a:r>
+              <a:t>benchmarks/ + eval/ — timing and RAGAS evaluation</a:t>
             </a:r>
           </a:p>
         </p:txBody>
@@ -5516,6 +5522,253 @@
 </file>
 
 <file path=ppt/slides/slide20.xml><?xml version="1.0" encoding="utf-8"?>
+<p:sld xmlns:a="http://schemas.openxmlformats.org/drawingml/2006/main" xmlns:p="http://schemas.openxmlformats.org/presentationml/2006/main" xmlns:r="http://schemas.openxmlformats.org/officeDocument/2006/relationships">
+  <p:cSld>
+    <p:bg>
+      <p:bgPr>
+        <a:solidFill>
+          <a:srgbClr val="FFFFFF"/>
+        </a:solidFill>
+        <a:effectLst/>
+      </p:bgPr>
+    </p:bg>
+    <p:spTree>
+      <p:nvGrpSpPr>
+        <p:cNvPr id="1" name=""/>
+        <p:cNvGrpSpPr/>
+        <p:nvPr/>
+      </p:nvGrpSpPr>
+      <p:grpSpPr/>
+      <p:sp>
+        <p:nvSpPr>
+          <p:cNvPr id="2" name="Rectangle 1"/>
+          <p:cNvSpPr/>
+          <p:nvPr/>
+        </p:nvSpPr>
+        <p:spPr>
+          <a:xfrm>
+            <a:off x="0" y="0"/>
+            <a:ext cx="9144000" cy="822960"/>
+          </a:xfrm>
+          <a:prstGeom prst="rect">
+            <a:avLst/>
+          </a:prstGeom>
+          <a:solidFill>
+            <a:srgbClr val="0D9488"/>
+          </a:solidFill>
+          <a:ln>
+            <a:noFill/>
+          </a:ln>
+        </p:spPr>
+        <p:style>
+          <a:lnRef idx="1">
+            <a:schemeClr val="accent1"/>
+          </a:lnRef>
+          <a:fillRef idx="3">
+            <a:schemeClr val="accent1"/>
+          </a:fillRef>
+          <a:effectRef idx="2">
+            <a:schemeClr val="accent1"/>
+          </a:effectRef>
+          <a:fontRef idx="minor">
+            <a:schemeClr val="lt1"/>
+          </a:fontRef>
+        </p:style>
+        <p:txBody>
+          <a:bodyPr rtlCol="0" anchor="ctr"/>
+          <a:lstStyle/>
+          <a:p>
+            <a:pPr algn="ctr"/>
+          </a:p>
+        </p:txBody>
+      </p:sp>
+      <p:sp>
+        <p:nvSpPr>
+          <p:cNvPr id="3" name="TextBox 2"/>
+          <p:cNvSpPr txBox="1"/>
+          <p:nvPr/>
+        </p:nvSpPr>
+        <p:spPr>
+          <a:xfrm>
+            <a:off x="457200" y="137160"/>
+            <a:ext cx="8229600" cy="640080"/>
+          </a:xfrm>
+          <a:prstGeom prst="rect">
+            <a:avLst/>
+          </a:prstGeom>
+          <a:noFill/>
+        </p:spPr>
+        <p:txBody>
+          <a:bodyPr wrap="none">
+            <a:spAutoFit/>
+          </a:bodyPr>
+          <a:lstStyle/>
+          <a:p>
+            <a:pPr>
+              <a:defRPr sz="2800" b="1">
+                <a:solidFill>
+                  <a:srgbClr val="FFFFFF"/>
+                </a:solidFill>
+              </a:defRPr>
+            </a:pPr>
+            <a:r>
+              <a:t>Handoff Checklist</a:t>
+            </a:r>
+          </a:p>
+        </p:txBody>
+      </p:sp>
+      <p:sp>
+        <p:nvSpPr>
+          <p:cNvPr id="4" name="TextBox 3"/>
+          <p:cNvSpPr txBox="1"/>
+          <p:nvPr/>
+        </p:nvSpPr>
+        <p:spPr>
+          <a:xfrm>
+            <a:off x="502920" y="1051560"/>
+            <a:ext cx="8229600" cy="5303520"/>
+          </a:xfrm>
+          <a:prstGeom prst="rect">
+            <a:avLst/>
+          </a:prstGeom>
+          <a:noFill/>
+        </p:spPr>
+        <p:txBody>
+          <a:bodyPr wrap="square" anchor="t">
+            <a:spAutoFit/>
+          </a:bodyPr>
+          <a:lstStyle/>
+          <a:p>
+            <a:pPr>
+              <a:spcAft>
+                <a:spcPts val="1000"/>
+              </a:spcAft>
+              <a:defRPr sz="1800">
+                <a:solidFill>
+                  <a:srgbClr val="1E293B"/>
+                </a:solidFill>
+              </a:defRPr>
+            </a:pPr>
+            <a:r>
+              <a:t>☐ Repo access transferred</a:t>
+            </a:r>
+          </a:p>
+          <a:p>
+            <a:pPr>
+              <a:spcAft>
+                <a:spcPts val="1000"/>
+              </a:spcAft>
+              <a:defRPr sz="1800">
+                <a:solidFill>
+                  <a:srgbClr val="1E293B"/>
+                </a:solidFill>
+              </a:defRPr>
+            </a:pPr>
+            <a:r>
+              <a:t>☐ Python 3.12 + pip install -r requirements.txt</a:t>
+            </a:r>
+          </a:p>
+          <a:p>
+            <a:pPr>
+              <a:spcAft>
+                <a:spcPts val="1000"/>
+              </a:spcAft>
+              <a:defRPr sz="1800">
+                <a:solidFill>
+                  <a:srgbClr val="1E293B"/>
+                </a:solidFill>
+              </a:defRPr>
+            </a:pPr>
+            <a:r>
+              <a:t>☐ .env from .env.example; CHATGPT_API_KEY set if using gpt51</a:t>
+            </a:r>
+          </a:p>
+          <a:p>
+            <a:pPr>
+              <a:spcAft>
+                <a:spcPts val="1000"/>
+              </a:spcAft>
+              <a:defRPr sz="1800">
+                <a:solidFill>
+                  <a:srgbClr val="1E293B"/>
+                </a:solidFill>
+              </a:defRPr>
+            </a:pPr>
+            <a:r>
+              <a:t>☐ Ollama running; mxbai-embed-large + qwen2.5:7b pulled</a:t>
+            </a:r>
+          </a:p>
+          <a:p>
+            <a:pPr>
+              <a:spcAft>
+                <a:spcPts val="1000"/>
+              </a:spcAft>
+              <a:defRPr sz="1800">
+                <a:solidFill>
+                  <a:srgbClr val="1E293B"/>
+                </a:solidFill>
+              </a:defRPr>
+            </a:pPr>
+            <a:r>
+              <a:t>☐ build_docindex.py completed; results/DocIndex.json exists</a:t>
+            </a:r>
+          </a:p>
+          <a:p>
+            <a:pPr>
+              <a:spcAft>
+                <a:spcPts val="1000"/>
+              </a:spcAft>
+              <a:defRPr sz="1800">
+                <a:solidFill>
+                  <a:srgbClr val="1E293B"/>
+                </a:solidFill>
+              </a:defRPr>
+            </a:pPr>
+            <a:r>
+              <a:t>☐ RAG chat: question + follow-up smoke test (port 5001)</a:t>
+            </a:r>
+          </a:p>
+          <a:p>
+            <a:pPr>
+              <a:spcAft>
+                <a:spcPts val="1000"/>
+              </a:spcAft>
+              <a:defRPr sz="1800">
+                <a:solidFill>
+                  <a:srgbClr val="1E293B"/>
+                </a:solidFill>
+              </a:defRPr>
+            </a:pPr>
+            <a:r>
+              <a:t>☐ DocIndex manager: upload, index, remove smoke test (port 5002)</a:t>
+            </a:r>
+          </a:p>
+          <a:p>
+            <a:pPr>
+              <a:spcAft>
+                <a:spcPts val="1000"/>
+              </a:spcAft>
+              <a:defRPr sz="1800">
+                <a:solidFill>
+                  <a:srgbClr val="1E293B"/>
+                </a:solidFill>
+              </a:defRPr>
+            </a:pPr>
+            <a:r>
+              <a:t>☐ README.md + handoff PPT reviewed by new maintainer</a:t>
+            </a:r>
+          </a:p>
+        </p:txBody>
+      </p:sp>
+    </p:spTree>
+  </p:cSld>
+  <p:clrMapOvr>
+    <a:masterClrMapping/>
+  </p:clrMapOvr>
+</p:sld>
+</file>
+
+<file path=ppt/slides/slide21.xml><?xml version="1.0" encoding="utf-8"?>
 <p:sld xmlns:a="http://schemas.openxmlformats.org/drawingml/2006/main" xmlns:p="http://schemas.openxmlformats.org/presentationml/2006/main" xmlns:r="http://schemas.openxmlformats.org/officeDocument/2006/relationships">
   <p:cSld>
     <p:bg>

</xml_diff>